<commit_message>
updated cp, maked .txt, deleted .docx
</commit_message>
<xml_diff>
--- a/CP/Курсовое проектирование 2026.pptx
+++ b/CP/Курсовое проектирование 2026.pptx
@@ -5,10 +5,10 @@
     <p:sldMasterId id="2147483648" r:id="rId1"/>
   </p:sldMasterIdLst>
   <p:notesMasterIdLst>
-    <p:notesMasterId r:id="rId24"/>
+    <p:notesMasterId r:id="rId23"/>
   </p:notesMasterIdLst>
   <p:handoutMasterIdLst>
-    <p:handoutMasterId r:id="rId25"/>
+    <p:handoutMasterId r:id="rId24"/>
   </p:handoutMasterIdLst>
   <p:sldIdLst>
     <p:sldId id="256" r:id="rId2"/>
@@ -32,7 +32,6 @@
     <p:sldId id="273" r:id="rId20"/>
     <p:sldId id="278" r:id="rId21"/>
     <p:sldId id="274" r:id="rId22"/>
-    <p:sldId id="277" r:id="rId23"/>
   </p:sldIdLst>
   <p:sldSz cx="9144000" cy="6858000" type="screen4x3"/>
   <p:notesSz cx="6858000" cy="9144000"/>
@@ -232,7 +231,7 @@
           <a:p>
             <a:fld id="{696C064A-D61B-4B21-B757-51A9B82445B8}" type="datetimeFigureOut">
               <a:rPr lang="en-US" smtClean="0"/>
-              <a:t>10/12/2026</a:t>
+              <a:t>10/19/2026</a:t>
             </a:fld>
             <a:endParaRPr lang="en-US"/>
           </a:p>
@@ -392,7 +391,7 @@
           <a:p>
             <a:fld id="{3EFD42F7-718C-4B98-AAEC-167E6DDD60A7}" type="datetimeFigureOut">
               <a:rPr lang="en-US" smtClean="0"/>
-              <a:t>10/12/2026</a:t>
+              <a:t>10/19/2026</a:t>
             </a:fld>
             <a:endParaRPr lang="en-US"/>
           </a:p>
@@ -849,7 +848,7 @@
           <a:p>
             <a:fld id="{B2DC9180-868E-4669-AA14-30A3E465E247}" type="datetimeFigureOut">
               <a:rPr lang="ru-RU" smtClean="0"/>
-              <a:t>12.10.2026</a:t>
+              <a:t>19.10.2026</a:t>
             </a:fld>
             <a:endParaRPr lang="ru-RU"/>
           </a:p>
@@ -1202,7 +1201,7 @@
           <a:p>
             <a:fld id="{B2DC9180-868E-4669-AA14-30A3E465E247}" type="datetimeFigureOut">
               <a:rPr lang="ru-RU" smtClean="0"/>
-              <a:t>12.10.2026</a:t>
+              <a:t>19.10.2026</a:t>
             </a:fld>
             <a:endParaRPr lang="ru-RU"/>
           </a:p>
@@ -1377,7 +1376,7 @@
           <a:p>
             <a:fld id="{B2DC9180-868E-4669-AA14-30A3E465E247}" type="datetimeFigureOut">
               <a:rPr lang="ru-RU" smtClean="0"/>
-              <a:t>12.10.2026</a:t>
+              <a:t>19.10.2026</a:t>
             </a:fld>
             <a:endParaRPr lang="ru-RU"/>
           </a:p>
@@ -1490,7 +1489,7 @@
           <a:p>
             <a:fld id="{B2DC9180-868E-4669-AA14-30A3E465E247}" type="datetimeFigureOut">
               <a:rPr lang="ru-RU" smtClean="0"/>
-              <a:t>12.10.2026</a:t>
+              <a:t>19.10.2026</a:t>
             </a:fld>
             <a:endParaRPr lang="ru-RU"/>
           </a:p>
@@ -1848,7 +1847,7 @@
           <a:p>
             <a:fld id="{B2DC9180-868E-4669-AA14-30A3E465E247}" type="datetimeFigureOut">
               <a:rPr lang="ru-RU" smtClean="0"/>
-              <a:t>12.10.2026</a:t>
+              <a:t>19.10.2026</a:t>
             </a:fld>
             <a:endParaRPr lang="ru-RU"/>
           </a:p>
@@ -2113,7 +2112,7 @@
           <a:p>
             <a:fld id="{B2DC9180-868E-4669-AA14-30A3E465E247}" type="datetimeFigureOut">
               <a:rPr lang="ru-RU" smtClean="0"/>
-              <a:t>12.10.2026</a:t>
+              <a:t>19.10.2026</a:t>
             </a:fld>
             <a:endParaRPr lang="ru-RU"/>
           </a:p>
@@ -2475,7 +2474,7 @@
           <a:p>
             <a:fld id="{B2DC9180-868E-4669-AA14-30A3E465E247}" type="datetimeFigureOut">
               <a:rPr lang="ru-RU" smtClean="0"/>
-              <a:t>12.10.2026</a:t>
+              <a:t>19.10.2026</a:t>
             </a:fld>
             <a:endParaRPr lang="ru-RU"/>
           </a:p>
@@ -2702,7 +2701,7 @@
           <a:p>
             <a:fld id="{B2DC9180-868E-4669-AA14-30A3E465E247}" type="datetimeFigureOut">
               <a:rPr lang="ru-RU" smtClean="0"/>
-              <a:t>12.10.2026</a:t>
+              <a:t>19.10.2026</a:t>
             </a:fld>
             <a:endParaRPr lang="ru-RU"/>
           </a:p>
@@ -2792,7 +2791,7 @@
           <a:p>
             <a:fld id="{B2DC9180-868E-4669-AA14-30A3E465E247}" type="datetimeFigureOut">
               <a:rPr lang="ru-RU" smtClean="0"/>
-              <a:t>12.10.2026</a:t>
+              <a:t>19.10.2026</a:t>
             </a:fld>
             <a:endParaRPr lang="ru-RU"/>
           </a:p>
@@ -3059,7 +3058,7 @@
           <a:p>
             <a:fld id="{B2DC9180-868E-4669-AA14-30A3E465E247}" type="datetimeFigureOut">
               <a:rPr lang="ru-RU" smtClean="0"/>
-              <a:t>12.10.2026</a:t>
+              <a:t>19.10.2026</a:t>
             </a:fld>
             <a:endParaRPr lang="ru-RU"/>
           </a:p>
@@ -3287,7 +3286,7 @@
           <a:p>
             <a:fld id="{B2DC9180-868E-4669-AA14-30A3E465E247}" type="datetimeFigureOut">
               <a:rPr lang="ru-RU" smtClean="0"/>
-              <a:t>12.10.2026</a:t>
+              <a:t>19.10.2026</a:t>
             </a:fld>
             <a:endParaRPr lang="ru-RU"/>
           </a:p>
@@ -3786,7 +3785,7 @@
           <a:p>
             <a:fld id="{B2DC9180-868E-4669-AA14-30A3E465E247}" type="datetimeFigureOut">
               <a:rPr lang="ru-RU" smtClean="0"/>
-              <a:t>12.10.2026</a:t>
+              <a:t>19.10.2026</a:t>
             </a:fld>
             <a:endParaRPr lang="ru-RU"/>
           </a:p>
@@ -4514,11 +4513,7 @@
             </a:r>
             <a:r>
               <a:rPr lang="ru-RU" sz="2300" dirty="0" smtClean="0"/>
-              <a:t> </a:t>
-            </a:r>
-            <a:r>
-              <a:rPr lang="ru-RU" sz="2300" dirty="0" smtClean="0"/>
-              <a:t>— постановка задачи и выбор темы,</a:t>
+              <a:t> — постановка задачи и выбор темы,</a:t>
             </a:r>
           </a:p>
           <a:p>
@@ -4543,15 +4538,7 @@
             </a:r>
             <a:r>
               <a:rPr lang="ru-RU" sz="2300" dirty="0" smtClean="0"/>
-              <a:t> </a:t>
-            </a:r>
-            <a:r>
-              <a:rPr lang="ru-RU" sz="2300" dirty="0" smtClean="0"/>
-              <a:t>по </a:t>
-            </a:r>
-            <a:r>
-              <a:rPr lang="ru-RU" sz="2300" dirty="0" smtClean="0"/>
-              <a:t>31.10.202</a:t>
+              <a:t> по 31.10.202</a:t>
             </a:r>
             <a:r>
               <a:rPr lang="ru-RU" sz="2300" dirty="0"/>
@@ -4559,21 +4546,13 @@
             </a:r>
             <a:r>
               <a:rPr lang="ru-RU" sz="2300" dirty="0" smtClean="0"/>
-              <a:t> </a:t>
-            </a:r>
+              <a:t> — сбор и анализ требований, </a:t>
+            </a:r>
+          </a:p>
+          <a:p>
             <a:r>
               <a:rPr lang="ru-RU" sz="2300" dirty="0" smtClean="0"/>
-              <a:t>— сбор и анализ требований, </a:t>
-            </a:r>
-          </a:p>
-          <a:p>
-            <a:r>
-              <a:rPr lang="ru-RU" sz="2300" dirty="0" smtClean="0"/>
-              <a:t>с </a:t>
-            </a:r>
-            <a:r>
-              <a:rPr lang="ru-RU" sz="2300" dirty="0" smtClean="0"/>
-              <a:t>01.11.202</a:t>
+              <a:t>с 01.11.202</a:t>
             </a:r>
             <a:r>
               <a:rPr lang="ru-RU" sz="2300" dirty="0"/>
@@ -4581,15 +4560,7 @@
             </a:r>
             <a:r>
               <a:rPr lang="ru-RU" sz="2300" dirty="0" smtClean="0"/>
-              <a:t> </a:t>
-            </a:r>
-            <a:r>
-              <a:rPr lang="ru-RU" sz="2300" dirty="0" smtClean="0"/>
-              <a:t>по </a:t>
-            </a:r>
-            <a:r>
-              <a:rPr lang="ru-RU" sz="2300" dirty="0" smtClean="0"/>
-              <a:t>07.11.202</a:t>
+              <a:t> по 07.11.202</a:t>
             </a:r>
             <a:r>
               <a:rPr lang="ru-RU" sz="2300" dirty="0"/>
@@ -4597,21 +4568,13 @@
             </a:r>
             <a:r>
               <a:rPr lang="ru-RU" sz="2300" dirty="0" smtClean="0"/>
-              <a:t> </a:t>
-            </a:r>
+              <a:t> — проектирование ПО,</a:t>
+            </a:r>
+          </a:p>
+          <a:p>
             <a:r>
               <a:rPr lang="ru-RU" sz="2300" dirty="0" smtClean="0"/>
-              <a:t>— проектирование ПО,</a:t>
-            </a:r>
-          </a:p>
-          <a:p>
-            <a:r>
-              <a:rPr lang="ru-RU" sz="2300" dirty="0" smtClean="0"/>
-              <a:t>с </a:t>
-            </a:r>
-            <a:r>
-              <a:rPr lang="ru-RU" sz="2300" dirty="0" smtClean="0"/>
-              <a:t>08.11.202</a:t>
+              <a:t>с 08.11.202</a:t>
             </a:r>
             <a:r>
               <a:rPr lang="ru-RU" sz="2300" dirty="0"/>
@@ -4619,11 +4582,7 @@
             </a:r>
             <a:r>
               <a:rPr lang="ru-RU" sz="2300" dirty="0" smtClean="0"/>
-              <a:t> </a:t>
-            </a:r>
-            <a:r>
-              <a:rPr lang="ru-RU" sz="2300" dirty="0" smtClean="0"/>
-              <a:t>по 2</a:t>
+              <a:t> по 2</a:t>
             </a:r>
             <a:r>
               <a:rPr lang="en-US" sz="2300" dirty="0" smtClean="0">
@@ -4642,11 +4601,7 @@
             </a:r>
             <a:r>
               <a:rPr lang="ru-RU" sz="2300" dirty="0" smtClean="0"/>
-              <a:t> </a:t>
-            </a:r>
-            <a:r>
-              <a:rPr lang="ru-RU" sz="2300" dirty="0" smtClean="0"/>
-              <a:t>— разработка и интеграция модулей ПО,</a:t>
+              <a:t> — разработка и интеграция модулей ПО,</a:t>
             </a:r>
           </a:p>
           <a:p>
@@ -4744,11 +4699,7 @@
             </a:r>
             <a:r>
               <a:rPr lang="ru-RU" sz="2300" dirty="0" smtClean="0"/>
-              <a:t> </a:t>
-            </a:r>
-            <a:r>
-              <a:rPr lang="ru-RU" sz="2300" dirty="0" smtClean="0"/>
-              <a:t>— написание и проверка программной документации, оформление пояснительной записки, </a:t>
+              <a:t> — написание и проверка программной документации, оформление пояснительной записки, </a:t>
             </a:r>
           </a:p>
           <a:p>
@@ -4762,11 +4713,7 @@
             </a:r>
             <a:r>
               <a:rPr lang="ru-RU" sz="2300" dirty="0" smtClean="0"/>
-              <a:t> </a:t>
-            </a:r>
-            <a:r>
-              <a:rPr lang="ru-RU" sz="2300" dirty="0" smtClean="0"/>
-              <a:t>— сдача курсового проекта на проверку, </a:t>
+              <a:t> — сдача курсового проекта на проверку, </a:t>
             </a:r>
           </a:p>
           <a:p>
@@ -4791,11 +4738,7 @@
             </a:r>
             <a:r>
               <a:rPr lang="ru-RU" sz="2300" dirty="0" smtClean="0"/>
-              <a:t> </a:t>
-            </a:r>
-            <a:r>
-              <a:rPr lang="ru-RU" sz="2300" dirty="0" smtClean="0"/>
-              <a:t>— защита курсового проекта.</a:t>
+              <a:t> — защита курсового проекта.</a:t>
             </a:r>
             <a:endParaRPr lang="ru-RU" sz="2300" dirty="0"/>
           </a:p>
@@ -4898,7 +4841,15 @@
             </a:r>
             <a:r>
               <a:rPr lang="en-US" dirty="0" smtClean="0"/>
-              <a:t>gitverse.ru, github.com </a:t>
+              <a:t>gitverse.ru</a:t>
+            </a:r>
+            <a:r>
+              <a:rPr lang="ru-RU" dirty="0" smtClean="0"/>
+              <a:t> /</a:t>
+            </a:r>
+            <a:r>
+              <a:rPr lang="en-US" dirty="0" smtClean="0"/>
+              <a:t> github.com </a:t>
             </a:r>
             <a:r>
               <a:rPr lang="ru-RU" dirty="0" smtClean="0"/>
@@ -4910,19 +4861,7 @@
             </a:r>
             <a:r>
               <a:rPr lang="ru-RU" dirty="0" smtClean="0"/>
-              <a:t> / </a:t>
-            </a:r>
-            <a:r>
-              <a:rPr lang="en-US" dirty="0" err="1" smtClean="0"/>
-              <a:t>gitlab</a:t>
-            </a:r>
-            <a:r>
-              <a:rPr lang="ru-RU" dirty="0"/>
-              <a:t> / </a:t>
-            </a:r>
-            <a:r>
-              <a:rPr lang="ru-RU" dirty="0" smtClean="0"/>
-              <a:t>и т.д.)</a:t>
+              <a:t> и т.д.)</a:t>
             </a:r>
             <a:r>
               <a:rPr lang="en-US" dirty="0" smtClean="0"/>
@@ -5398,34 +5337,14 @@
             </a:r>
             <a:r>
               <a:rPr lang="ru-RU" dirty="0" smtClean="0"/>
-              <a:t>. Отсканированные титульный лист и лист </a:t>
-            </a:r>
-            <a:r>
-              <a:rPr lang="ru-RU" dirty="0" smtClean="0"/>
-              <a:t>задания </a:t>
-            </a:r>
-            <a:r>
-              <a:rPr lang="ru-RU" dirty="0" smtClean="0"/>
-              <a:t>с подписями должны быть </a:t>
-            </a:r>
-            <a:r>
-              <a:rPr lang="ru-RU" dirty="0" smtClean="0"/>
-              <a:t>вставлены в файлы </a:t>
-            </a:r>
-            <a:r>
-              <a:rPr lang="ru-RU" dirty="0" smtClean="0"/>
-              <a:t>с пояснительной запиской,</a:t>
+              <a:t>. Отсканированные титульный лист и лист задания с подписями должны быть вставлены в файлы с пояснительной запиской,</a:t>
             </a:r>
           </a:p>
           <a:p>
             <a:pPr lvl="0"/>
             <a:r>
               <a:rPr lang="ru-RU" dirty="0" smtClean="0"/>
-              <a:t>все исходные </a:t>
-            </a:r>
-            <a:r>
-              <a:rPr lang="ru-RU" dirty="0" smtClean="0"/>
-              <a:t>файлы приложения,</a:t>
+              <a:t>все исходные файлы приложения,</a:t>
             </a:r>
           </a:p>
           <a:p>
@@ -5801,11 +5720,7 @@
             </a:r>
             <a:r>
               <a:rPr lang="ru-RU" i="1" dirty="0" smtClean="0"/>
-              <a:t>(на все – ссылки в </a:t>
-            </a:r>
-            <a:r>
-              <a:rPr lang="ru-RU" i="1" dirty="0" smtClean="0"/>
-              <a:t>ПЗ в </a:t>
+              <a:t>(на все – ссылки в ПЗ в </a:t>
             </a:r>
             <a:r>
               <a:rPr lang="en-US" i="1" dirty="0" smtClean="0"/>
@@ -5941,7 +5856,7 @@
             </a:pPr>
             <a:r>
               <a:rPr lang="ru-RU" dirty="0" smtClean="0"/>
-              <a:t>Кратко описать ПО (какой будет тип приложения (оконное/веб, его основная функциональность, эксплуатационные требования к интерфейсу и защите данных). Этот же текст может использоваться в листе задания.</a:t>
+              <a:t>Кратко описать ПО (какой будет тип приложения (оконное/веб/мобильное, его основная функциональность, эксплуатационные требования к интерфейсу и защите данных). Этот же текст может использоваться в листе задания.</a:t>
             </a:r>
           </a:p>
           <a:p>
@@ -6190,11 +6105,7 @@
             </a:r>
             <a:r>
               <a:rPr lang="ru-RU" sz="2100" dirty="0" smtClean="0"/>
-              <a:t>модель </a:t>
-            </a:r>
-            <a:r>
-              <a:rPr lang="ru-RU" sz="2100" dirty="0" smtClean="0"/>
-              <a:t>БД</a:t>
+              <a:t>модель БД</a:t>
             </a:r>
             <a:endParaRPr lang="ru-RU" sz="2100" dirty="0"/>
           </a:p>
@@ -6256,15 +6167,7 @@
           <a:p>
             <a:r>
               <a:rPr lang="ru-RU" dirty="0" smtClean="0"/>
-              <a:t>3 Разработка </a:t>
-            </a:r>
-            <a:r>
-              <a:rPr lang="ru-RU" dirty="0" smtClean="0"/>
-              <a:t>модулей </a:t>
-            </a:r>
-            <a:r>
-              <a:rPr lang="ru-RU" dirty="0" smtClean="0"/>
-              <a:t>ПО</a:t>
+              <a:t>3 Разработка модулей ПО</a:t>
             </a:r>
             <a:endParaRPr lang="ru-RU" dirty="0"/>
           </a:p>
@@ -6288,7 +6191,7 @@
         </p:spPr>
         <p:txBody>
           <a:bodyPr>
-            <a:normAutofit fontScale="85000" lnSpcReduction="20000"/>
+            <a:normAutofit fontScale="92500"/>
           </a:bodyPr>
           <a:lstStyle/>
           <a:p>
@@ -6359,89 +6262,6 @@
               <a:rPr lang="ru-RU" dirty="0" smtClean="0"/>
               <a:t>прав доступа, авторизации и регистрации</a:t>
             </a:r>
-            <a:endParaRPr lang="ru-RU" dirty="0"/>
-          </a:p>
-          <a:p>
-            <a:r>
-              <a:rPr lang="ru-RU" b="1" dirty="0" smtClean="0"/>
-              <a:t>3.</a:t>
-            </a:r>
-            <a:r>
-              <a:rPr lang="en-US" b="1" dirty="0" smtClean="0">
-                <a:latin typeface="Cambria" panose="02040503050406030204" pitchFamily="18" charset="0"/>
-                <a:ea typeface="Cambria" panose="02040503050406030204" pitchFamily="18" charset="0"/>
-              </a:rPr>
-              <a:t>4</a:t>
-            </a:r>
-            <a:r>
-              <a:rPr lang="ru-RU" b="1" dirty="0" smtClean="0"/>
-              <a:t> Экспорт и импорт данных</a:t>
-            </a:r>
-            <a:endParaRPr lang="ru-RU" b="1" dirty="0"/>
-          </a:p>
-          <a:p>
-            <a:pPr marL="0" indent="0">
-              <a:buNone/>
-            </a:pPr>
-            <a:r>
-              <a:rPr lang="ru-RU" dirty="0"/>
-              <a:t>Здесь: </a:t>
-            </a:r>
-            <a:r>
-              <a:rPr lang="ru-RU" dirty="0" smtClean="0"/>
-              <a:t>листинги формирования </a:t>
-            </a:r>
-            <a:r>
-              <a:rPr lang="ru-RU" dirty="0"/>
-              <a:t>отчетов в виде </a:t>
-            </a:r>
-            <a:r>
-              <a:rPr lang="ru-RU" dirty="0" smtClean="0"/>
-              <a:t>документов, таблиц </a:t>
-            </a:r>
-            <a:r>
-              <a:rPr lang="ru-RU" dirty="0"/>
-              <a:t>и графиков, экспорт </a:t>
-            </a:r>
-            <a:r>
-              <a:rPr lang="ru-RU" dirty="0" smtClean="0"/>
-              <a:t>и импорт данных в формате </a:t>
-            </a:r>
-            <a:r>
-              <a:rPr lang="en-US" dirty="0" err="1" smtClean="0"/>
-              <a:t>docx</a:t>
-            </a:r>
-            <a:r>
-              <a:rPr lang="en-US" dirty="0" smtClean="0"/>
-              <a:t>/</a:t>
-            </a:r>
-            <a:r>
-              <a:rPr lang="en-US" dirty="0" err="1" smtClean="0"/>
-              <a:t>xlsx</a:t>
-            </a:r>
-            <a:r>
-              <a:rPr lang="en-US" dirty="0" smtClean="0"/>
-              <a:t>/csv/html/pdf</a:t>
-            </a:r>
-            <a:r>
-              <a:rPr lang="en-US" dirty="0"/>
-              <a:t>/</a:t>
-            </a:r>
-            <a:r>
-              <a:rPr lang="en-US" dirty="0" err="1" smtClean="0"/>
-              <a:t>json</a:t>
-            </a:r>
-            <a:r>
-              <a:rPr lang="en-US" dirty="0" smtClean="0"/>
-              <a:t>/txt</a:t>
-            </a:r>
-            <a:endParaRPr lang="ru-RU" dirty="0"/>
-          </a:p>
-          <a:p>
-            <a:pPr marL="0" indent="0">
-              <a:buNone/>
-            </a:pPr>
-            <a:endParaRPr lang="ru-RU" dirty="0" smtClean="0"/>
           </a:p>
           <a:p>
             <a:endParaRPr lang="ru-RU" dirty="0"/>
@@ -6656,7 +6476,7 @@
         <p:spPr/>
         <p:txBody>
           <a:bodyPr>
-            <a:normAutofit fontScale="92500" lnSpcReduction="10000"/>
+            <a:normAutofit fontScale="92500" lnSpcReduction="20000"/>
           </a:bodyPr>
           <a:lstStyle/>
           <a:p>
@@ -6750,7 +6570,7 @@
           <a:p>
             <a:r>
               <a:rPr lang="ru-RU" dirty="0" smtClean="0"/>
-              <a:t>Разработка веб-сайта «</a:t>
+              <a:t>Разработка веб-приложения «</a:t>
             </a:r>
             <a:r>
               <a:rPr lang="ru-RU" dirty="0" smtClean="0">
@@ -6768,11 +6588,29 @@
           <a:p>
             <a:r>
               <a:rPr lang="ru-RU" dirty="0" smtClean="0"/>
-              <a:t>Разработка игрового приложения </a:t>
-            </a:r>
-            <a:r>
-              <a:rPr lang="ru-RU" dirty="0" smtClean="0"/>
+              <a:t>Разработка сервиса </a:t>
+            </a:r>
+            <a:r>
+              <a:rPr lang="ru-RU" dirty="0"/>
               <a:t>«</a:t>
+            </a:r>
+            <a:r>
+              <a:rPr lang="ru-RU" dirty="0">
+                <a:solidFill>
+                  <a:srgbClr val="FF0000"/>
+                </a:solidFill>
+              </a:rPr>
+              <a:t>…</a:t>
+            </a:r>
+            <a:r>
+              <a:rPr lang="ru-RU" dirty="0"/>
+              <a:t>»</a:t>
+            </a:r>
+          </a:p>
+          <a:p>
+            <a:r>
+              <a:rPr lang="ru-RU" dirty="0" smtClean="0"/>
+              <a:t>Разработка игрового приложения «</a:t>
             </a:r>
             <a:r>
               <a:rPr lang="ru-RU" dirty="0" smtClean="0">
@@ -7304,103 +7142,30 @@
             </a:r>
             <a:r>
               <a:rPr lang="ru-RU" sz="1400" dirty="0"/>
-              <a:t>– Режим доступа: по подписке. – Текст : электронный.</a:t>
-            </a:r>
-          </a:p>
-        </p:txBody>
-      </p:sp>
-    </p:spTree>
-  </p:cSld>
-  <p:clrMapOvr>
-    <a:masterClrMapping/>
-  </p:clrMapOvr>
-</p:sld>
-</file>
-
-<file path=ppt/slides/slide22.xml><?xml version="1.0" encoding="utf-8"?>
-<p:sld xmlns:a="http://schemas.openxmlformats.org/drawingml/2006/main" xmlns:r="http://schemas.openxmlformats.org/officeDocument/2006/relationships" xmlns:p="http://schemas.openxmlformats.org/presentationml/2006/main">
-  <p:cSld>
-    <p:spTree>
-      <p:nvGrpSpPr>
-        <p:cNvPr id="1" name=""/>
-        <p:cNvGrpSpPr/>
-        <p:nvPr/>
-      </p:nvGrpSpPr>
-      <p:grpSpPr>
-        <a:xfrm>
-          <a:off x="0" y="0"/>
-          <a:ext cx="0" cy="0"/>
-          <a:chOff x="0" y="0"/>
-          <a:chExt cx="0" cy="0"/>
-        </a:xfrm>
-      </p:grpSpPr>
-      <p:sp>
-        <p:nvSpPr>
-          <p:cNvPr id="2" name="Заголовок 1"/>
-          <p:cNvSpPr>
-            <a:spLocks noGrp="1"/>
-          </p:cNvSpPr>
-          <p:nvPr>
-            <p:ph type="title"/>
-          </p:nvPr>
-        </p:nvSpPr>
-        <p:spPr/>
-        <p:txBody>
-          <a:bodyPr>
-            <a:normAutofit fontScale="90000"/>
-          </a:bodyPr>
-          <a:lstStyle/>
-          <a:p>
-            <a:r>
-              <a:rPr lang="ru-RU" dirty="0"/>
-              <a:t>Список использованных источников</a:t>
-            </a:r>
-          </a:p>
-        </p:txBody>
-      </p:sp>
-      <p:sp>
-        <p:nvSpPr>
-          <p:cNvPr id="3" name="Содержимое 2"/>
-          <p:cNvSpPr>
-            <a:spLocks noGrp="1"/>
-          </p:cNvSpPr>
-          <p:nvPr>
-            <p:ph sz="quarter" idx="1"/>
-          </p:nvPr>
-        </p:nvSpPr>
-        <p:spPr>
-          <a:xfrm>
-            <a:off x="914400" y="1447800"/>
-            <a:ext cx="7772400" cy="5340350"/>
-          </a:xfrm>
-        </p:spPr>
-        <p:txBody>
-          <a:bodyPr>
-            <a:noAutofit/>
-          </a:bodyPr>
-          <a:lstStyle/>
+              <a:t>– Режим доступа: по подписке. – Текст : электронный</a:t>
+            </a:r>
+            <a:r>
+              <a:rPr lang="ru-RU" sz="1400" dirty="0" smtClean="0"/>
+              <a:t>.</a:t>
+            </a:r>
+          </a:p>
           <a:p>
             <a:pPr marL="0" indent="0">
               <a:buNone/>
             </a:pPr>
             <a:r>
-              <a:rPr lang="ru-RU" sz="2800" dirty="0" smtClean="0"/>
+              <a:rPr lang="ru-RU" sz="1400" b="1" dirty="0"/>
               <a:t>На все источники должна быть ссылка в тексте (указывается в </a:t>
             </a:r>
             <a:r>
-              <a:rPr lang="en-US" sz="2800" dirty="0" smtClean="0"/>
+              <a:rPr lang="en-US" sz="1400" b="1" dirty="0" smtClean="0"/>
               <a:t>[…])</a:t>
             </a:r>
-            <a:endParaRPr lang="ru-RU" sz="2800" dirty="0" smtClean="0"/>
+            <a:endParaRPr lang="ru-RU" sz="1400" b="1" dirty="0"/>
           </a:p>
         </p:txBody>
       </p:sp>
     </p:spTree>
-    <p:extLst>
-      <p:ext uri="{BB962C8B-B14F-4D97-AF65-F5344CB8AC3E}">
-        <p14:creationId xmlns:p14="http://schemas.microsoft.com/office/powerpoint/2010/main" val="613101769"/>
-      </p:ext>
-    </p:extLst>
   </p:cSld>
   <p:clrMapOvr>
     <a:masterClrMapping/>
@@ -7743,15 +7508,7 @@
           <a:p>
             <a:r>
               <a:rPr lang="ru-RU" dirty="0" smtClean="0"/>
-              <a:t>задачи берутся из этапов создания </a:t>
-            </a:r>
-            <a:r>
-              <a:rPr lang="ru-RU" dirty="0" smtClean="0"/>
-              <a:t>своего ПО (от сбора и анализа требований до внедрения), </a:t>
-            </a:r>
-            <a:r>
-              <a:rPr lang="ru-RU" dirty="0" smtClean="0"/>
-              <a:t>требований к проекту, из ФГОС 09.02.07.</a:t>
+              <a:t>задачи берутся из этапов создания своего ПО (от сбора и анализа требований до внедрения), требований к проекту, из ФГОС 09.02.07.</a:t>
             </a:r>
           </a:p>
           <a:p>
@@ -7871,13 +7628,8 @@
             <a:pPr lvl="0"/>
             <a:r>
               <a:rPr lang="ru-RU" dirty="0" smtClean="0"/>
-              <a:t>реализовать экспорт данных и формирование </a:t>
-            </a:r>
-            <a:r>
-              <a:rPr lang="ru-RU" dirty="0" smtClean="0"/>
-              <a:t>отчетов в формате …,</a:t>
-            </a:r>
-            <a:endParaRPr lang="ru-RU" dirty="0" smtClean="0"/>
+              <a:t>реализовать экспорт данных и формирование отчетов в формате …,</a:t>
+            </a:r>
           </a:p>
           <a:p>
             <a:pPr lvl="0"/>
@@ -7908,11 +7660,7 @@
             <a:pPr lvl="0"/>
             <a:r>
               <a:rPr lang="ru-RU" dirty="0" smtClean="0"/>
-              <a:t>выполнить </a:t>
-            </a:r>
-            <a:r>
-              <a:rPr lang="ru-RU" dirty="0" smtClean="0"/>
-              <a:t>тестирование и отладку ПО и проанализировать результаты тестирования,</a:t>
+              <a:t>выполнить тестирование и отладку ПО и проанализировать результаты тестирования,</a:t>
             </a:r>
           </a:p>
           <a:p>

</xml_diff>